<commit_message>
Due core: una coda d'uscita per core, thread pktgen in parti uguali
Banco:
- netns_fabric: port_queues, le veth d'uscita con N code
- bench_throughput: --egress-queues (auto = una coda per core del DUT, senza
  collisioni CPU modulo code); --egress-cpu accetta una lista, un core
  d'uscita per coda (pin_egress_napi) con verifica a fine run; auto prende un
  core d'uscita per core del DUT; avviso se i thread pktgen non si dividono in
  parti uguali fra le code; env.csv non legge piu' il registro di un run
  precedente nella stessa cartella
- host_conditions: l'uscita puo' essere una lista di CPU
- remeasure_traffic.sh: due core con 4 thread pktgen, piu' xdp_gen a due core

Risultati (2026-10-01): con xdp_gen due core elaborano il 95-99% del doppio e
il costo per core e' quello di un core; con pktgen rapporti 1,93-2,04 (rxonly
compreso, con 4 thread). Documenti, slide 14, 23, 24 e spiegazioni aggiornati.

Co-Authored-By: Claude Opus 5.5 <noreply@anthropic.com>
</commit_message>
<xml_diff>
--- a/docs/Test reale su dual boot.pptx
+++ b/docs/Test reale su dual boot.pptx
@@ -11290,7 +11290,7 @@
                 <a:ea typeface="Carlito"/>
                 <a:cs typeface="Carlito"/>
               </a:rPr>
-              <a:t>Con xdp_gen si contano i pacchetti elaborati</a:t>
+              <a:t>Con xdp_gen due core reggono il doppio</a:t>
             </a:r>
             <a:endParaRPr lang="en-US" sz="3000"/>
           </a:p>
@@ -11367,7 +11367,7 @@
                 <a:ea typeface="Carlito"/>
                 <a:cs typeface="Carlito"/>
               </a:rPr>
-              <a:t>Milioni di pacchetti al secondo, con xdp_gen</a:t>
+              <a:t>Milioni di pacchetti al secondo elaborati, con xdp_gen</a:t>
             </a:r>
             <a:endParaRPr lang="en-US" sz="1500"/>
           </a:p>
@@ -11444,7 +11444,7 @@
                 <a:ea typeface="Carlito"/>
                 <a:cs typeface="Carlito"/>
               </a:rPr>
-              <a:t>elaborati dal nodo</a:t>
+              <a:t>2 core, misurati</a:t>
             </a:r>
             <a:endParaRPr lang="en-US" sz="1200"/>
           </a:p>
@@ -11521,7 +11521,7 @@
                 <a:ea typeface="Carlito"/>
                 <a:cs typeface="Carlito"/>
               </a:rPr>
-              <a:t>arrivati all'uscita</a:t>
+              <a:t>2 × un core</a:t>
             </a:r>
             <a:endParaRPr lang="en-US" sz="1200"/>
           </a:p>
@@ -11535,7 +11535,7 @@
         </p:nvSpPr>
         <p:spPr bwMode="auto">
           <a:xfrm>
-            <a:off x="836016" y="2317200"/>
+            <a:off x="836016" y="2443218"/>
             <a:ext cx="420000" cy="238720"/>
           </a:xfrm>
           <a:prstGeom prst="rect">
@@ -11566,7 +11566,7 @@
                 <a:ea typeface="Carlito"/>
                 <a:cs typeface="Carlito"/>
               </a:rPr>
-              <a:t>13,05</a:t>
+              <a:t>28,33</a:t>
             </a:r>
             <a:endParaRPr lang="en-US" sz="1200"/>
           </a:p>
@@ -11580,8 +11580,8 @@
         </p:nvSpPr>
         <p:spPr bwMode="auto">
           <a:xfrm>
-            <a:off x="736600" y="2530520"/>
-            <a:ext cx="469900" cy="1950000"/>
+            <a:off x="736600" y="2658102"/>
+            <a:ext cx="469900" cy="1822458"/>
           </a:xfrm>
           <a:custGeom>
             <a:avLst/>
@@ -11636,7 +11636,7 @@
         </p:nvSpPr>
         <p:spPr bwMode="auto">
           <a:xfrm>
-            <a:off x="1356717" y="3630648"/>
+            <a:off x="1356717" y="2345388"/>
             <a:ext cx="420000" cy="238720"/>
           </a:xfrm>
           <a:prstGeom prst="rect">
@@ -11667,7 +11667,7 @@
                 <a:ea typeface="Carlito"/>
                 <a:cs typeface="Carlito"/>
               </a:rPr>
-              <a:t>4,26</a:t>
+              <a:t>29,85</a:t>
             </a:r>
             <a:endParaRPr lang="en-US" sz="1200"/>
           </a:p>
@@ -11681,8 +11681,8 @@
         </p:nvSpPr>
         <p:spPr bwMode="auto">
           <a:xfrm>
-            <a:off x="1257300" y="3843968"/>
-            <a:ext cx="469900" cy="636551"/>
+            <a:off x="1257300" y="2560272"/>
+            <a:ext cx="469900" cy="1920288"/>
           </a:xfrm>
           <a:custGeom>
             <a:avLst/>
@@ -11737,7 +11737,7 @@
         </p:nvSpPr>
         <p:spPr bwMode="auto">
           <a:xfrm>
-            <a:off x="2112367" y="2717659"/>
+            <a:off x="2112367" y="3168856"/>
             <a:ext cx="420000" cy="238720"/>
           </a:xfrm>
           <a:prstGeom prst="rect">
@@ -11768,7 +11768,7 @@
                 <a:ea typeface="Carlito"/>
                 <a:cs typeface="Carlito"/>
               </a:rPr>
-              <a:t>10,37</a:t>
+              <a:t>17,05</a:t>
             </a:r>
             <a:endParaRPr lang="en-US" sz="1200"/>
           </a:p>
@@ -11782,8 +11782,8 @@
         </p:nvSpPr>
         <p:spPr bwMode="auto">
           <a:xfrm>
-            <a:off x="2012949" y="2930979"/>
-            <a:ext cx="469900" cy="1549540"/>
+            <a:off x="2012949" y="3383740"/>
+            <a:ext cx="469900" cy="1096820"/>
           </a:xfrm>
           <a:custGeom>
             <a:avLst/>
@@ -11838,7 +11838,7 @@
         </p:nvSpPr>
         <p:spPr bwMode="auto">
           <a:xfrm>
-            <a:off x="2633067" y="3693406"/>
+            <a:off x="2633067" y="3156545"/>
             <a:ext cx="420000" cy="238720"/>
           </a:xfrm>
           <a:prstGeom prst="rect">
@@ -11869,7 +11869,7 @@
                 <a:ea typeface="Carlito"/>
                 <a:cs typeface="Carlito"/>
               </a:rPr>
-              <a:t>3,84</a:t>
+              <a:t>17,24</a:t>
             </a:r>
             <a:endParaRPr lang="en-US" sz="1200"/>
           </a:p>
@@ -11883,8 +11883,8 @@
         </p:nvSpPr>
         <p:spPr bwMode="auto">
           <a:xfrm>
-            <a:off x="2533650" y="3906726"/>
-            <a:ext cx="469900" cy="573793"/>
+            <a:off x="2533650" y="3371429"/>
+            <a:ext cx="469900" cy="1109131"/>
           </a:xfrm>
           <a:custGeom>
             <a:avLst/>
@@ -11939,7 +11939,7 @@
         </p:nvSpPr>
         <p:spPr bwMode="auto">
           <a:xfrm>
-            <a:off x="3388717" y="2749039"/>
+            <a:off x="3388717" y="3248625"/>
             <a:ext cx="420000" cy="238720"/>
           </a:xfrm>
           <a:prstGeom prst="rect">
@@ -11970,7 +11970,7 @@
                 <a:ea typeface="Carlito"/>
                 <a:cs typeface="Carlito"/>
               </a:rPr>
-              <a:t>10,16</a:t>
+              <a:t>15,81</a:t>
             </a:r>
             <a:endParaRPr lang="en-US" sz="1200"/>
           </a:p>
@@ -11984,8 +11984,8 @@
         </p:nvSpPr>
         <p:spPr bwMode="auto">
           <a:xfrm>
-            <a:off x="3289300" y="2962359"/>
-            <a:ext cx="469900" cy="1518160"/>
+            <a:off x="3289300" y="3463509"/>
+            <a:ext cx="469900" cy="1017051"/>
           </a:xfrm>
           <a:custGeom>
             <a:avLst/>
@@ -12040,7 +12040,7 @@
         </p:nvSpPr>
         <p:spPr bwMode="auto">
           <a:xfrm>
-            <a:off x="3909417" y="3681452"/>
+            <a:off x="3909417" y="3236402"/>
             <a:ext cx="420000" cy="238720"/>
           </a:xfrm>
           <a:prstGeom prst="rect">
@@ -12071,7 +12071,7 @@
                 <a:ea typeface="Carlito"/>
                 <a:cs typeface="Carlito"/>
               </a:rPr>
-              <a:t>3,92</a:t>
+              <a:t>16,00</a:t>
             </a:r>
             <a:endParaRPr lang="en-US" sz="1200"/>
           </a:p>
@@ -12085,8 +12085,8 @@
         </p:nvSpPr>
         <p:spPr bwMode="auto">
           <a:xfrm>
-            <a:off x="3810000" y="3894772"/>
-            <a:ext cx="469900" cy="585747"/>
+            <a:off x="3810000" y="3451286"/>
+            <a:ext cx="469900" cy="1029274"/>
           </a:xfrm>
           <a:custGeom>
             <a:avLst/>
@@ -12141,7 +12141,7 @@
         </p:nvSpPr>
         <p:spPr bwMode="auto">
           <a:xfrm>
-            <a:off x="4665067" y="3289958"/>
+            <a:off x="4665067" y="3835954"/>
             <a:ext cx="420000" cy="238720"/>
           </a:xfrm>
           <a:prstGeom prst="rect">
@@ -12172,7 +12172,7 @@
                 <a:ea typeface="Carlito"/>
                 <a:cs typeface="Carlito"/>
               </a:rPr>
-              <a:t>6,54</a:t>
+              <a:t>6,68</a:t>
             </a:r>
             <a:endParaRPr lang="en-US" sz="1200"/>
           </a:p>
@@ -12186,8 +12186,8 @@
         </p:nvSpPr>
         <p:spPr bwMode="auto">
           <a:xfrm>
-            <a:off x="4565650" y="3503278"/>
-            <a:ext cx="469900" cy="977241"/>
+            <a:off x="4565650" y="4050838"/>
+            <a:ext cx="469900" cy="429722"/>
           </a:xfrm>
           <a:custGeom>
             <a:avLst/>
@@ -12242,7 +12242,7 @@
         </p:nvSpPr>
         <p:spPr bwMode="auto">
           <a:xfrm>
-            <a:off x="5185767" y="3373636"/>
+            <a:off x="5185767" y="3826566"/>
             <a:ext cx="420000" cy="238720"/>
           </a:xfrm>
           <a:prstGeom prst="rect">
@@ -12273,7 +12273,7 @@
                 <a:ea typeface="Carlito"/>
                 <a:cs typeface="Carlito"/>
               </a:rPr>
-              <a:t>5,98</a:t>
+              <a:t>6,83</a:t>
             </a:r>
             <a:endParaRPr lang="en-US" sz="1200"/>
           </a:p>
@@ -12287,8 +12287,8 @@
         </p:nvSpPr>
         <p:spPr bwMode="auto">
           <a:xfrm>
-            <a:off x="5086350" y="3586956"/>
-            <a:ext cx="469900" cy="893563"/>
+            <a:off x="5086350" y="4041450"/>
+            <a:ext cx="469900" cy="439110"/>
           </a:xfrm>
           <a:custGeom>
             <a:avLst/>
@@ -12343,7 +12343,7 @@
         </p:nvSpPr>
         <p:spPr bwMode="auto">
           <a:xfrm>
-            <a:off x="5941417" y="3569383"/>
+            <a:off x="5941417" y="3969117"/>
             <a:ext cx="420000" cy="238720"/>
           </a:xfrm>
           <a:prstGeom prst="rect">
@@ -12374,7 +12374,7 @@
                 <a:ea typeface="Carlito"/>
                 <a:cs typeface="Carlito"/>
               </a:rPr>
-              <a:t>4,67</a:t>
+              <a:t>4,61</a:t>
             </a:r>
             <a:endParaRPr lang="en-US" sz="1200"/>
           </a:p>
@@ -12388,8 +12388,8 @@
         </p:nvSpPr>
         <p:spPr bwMode="auto">
           <a:xfrm>
-            <a:off x="5842000" y="3782703"/>
-            <a:ext cx="469900" cy="697816"/>
+            <a:off x="5842000" y="4184001"/>
+            <a:ext cx="469900" cy="296559"/>
           </a:xfrm>
           <a:custGeom>
             <a:avLst/>
@@ -12444,7 +12444,7 @@
         </p:nvSpPr>
         <p:spPr bwMode="auto">
           <a:xfrm>
-            <a:off x="6462117" y="3569383"/>
+            <a:off x="6462117" y="3965071"/>
             <a:ext cx="420000" cy="238720"/>
           </a:xfrm>
           <a:prstGeom prst="rect">
@@ -12489,8 +12489,8 @@
         </p:nvSpPr>
         <p:spPr bwMode="auto">
           <a:xfrm>
-            <a:off x="6362700" y="3782703"/>
-            <a:ext cx="469900" cy="697816"/>
+            <a:off x="6362700" y="4179955"/>
+            <a:ext cx="469900" cy="300605"/>
           </a:xfrm>
           <a:custGeom>
             <a:avLst/>
@@ -12880,7 +12880,7 @@
                 <a:ea typeface="Carlito"/>
                 <a:cs typeface="Carlito"/>
               </a:rPr>
-              <a:t>Due core, le stesse code d'uscita</a:t>
+              <a:t>Una coda d'uscita per ogni core</a:t>
             </a:r>
             <a:endParaRPr lang="en-US" sz="1500"/>
           </a:p>
@@ -12925,7 +12925,7 @@
                 <a:ea typeface="Carlito"/>
                 <a:cs typeface="Carlito"/>
               </a:rPr>
-              <a:t>Con due core sul nodo, tutti e due inoltrano nelle stesse code verso il nodo successivo: due scrittori per coda. Le code si intasano e metà dei pacchetti della baseline si perde dopo il nodo, con il core d'uscita occupato solo al 77%.</a:t>
+              <a:t>Prima i due core del nodo scrivevano nella stessa coda d'uscita, svuotata da un solo core: la baseline elaborava 13,1 M/s e ne arrivavano 4,3. Ora ogni core ha la sua coda e il suo core d'uscita: arrivano tutti.</a:t>
             </a:r>
             <a:endParaRPr lang="en-US" sz="1300"/>
           </a:p>
@@ -13049,7 +13049,7 @@
                 <a:ea typeface="Carlito"/>
                 <a:cs typeface="Carlito"/>
               </a:rPr>
-              <a:t>Un esempio: baseline e P2</a:t>
+              <a:t>Il costo per core non cambia</a:t>
             </a:r>
             <a:endParaRPr lang="en-US" sz="1500"/>
           </a:p>
@@ -13094,7 +13094,7 @@
                 <a:ea typeface="Carlito"/>
                 <a:cs typeface="Carlito"/>
               </a:rPr>
-              <a:t>La baseline elabora 13,1 M/s ma ne arrivano 4,3; P2 ne elabora 6,5 e ne arrivano 6,0. Contando gli arrivi la baseline sembrerebbe più lenta di P2, che fa molto più lavoro.</a:t>
+              <a:t>Tempo di CPU per pacchetto di ogni core: 68, 117, 127, 298 e 434 ns, contro 67, 116, 125, 293 e 428 con un core solo (slide 13).</a:t>
             </a:r>
             <a:endParaRPr lang="en-US" sz="1300"/>
           </a:p>
@@ -13263,7 +13263,7 @@
                 <a:ea typeface="Carlito"/>
                 <a:cs typeface="Carlito"/>
               </a:rPr>
-              <a:t>Il controllo di validità (la baseline deve essere la più veloce) conta i pacchetti </a:t>
+              <a:t>Con uno scrittore per coda anche in uscita, due core elaborano il </a:t>
             </a:r>
             <a:r>
               <a:rPr lang="en-US" sz="1500" b="1">
@@ -13274,7 +13274,7 @@
                 <a:ea typeface="Carlito"/>
                 <a:cs typeface="Carlito"/>
               </a:rPr>
-              <a:t>elaborati</a:t>
+              <a:t>95–99% del doppio</a:t>
             </a:r>
             <a:r>
               <a:rPr lang="en-US" sz="1500">
@@ -13285,7 +13285,7 @@
                 <a:ea typeface="Carlito"/>
                 <a:cs typeface="Carlito"/>
               </a:rPr>
-              <a:t>: la stessa grandezza con cui si calcola il costo.</a:t>
+              <a:t> di un core: il costo misurato su un core vale per ogni core.</a:t>
             </a:r>
             <a:endParaRPr lang="en-US" sz="1500"/>
           </a:p>
@@ -13330,7 +13330,7 @@
                 <a:ea typeface="Carlito"/>
                 <a:cs typeface="Carlito"/>
               </a:rPr>
-              <a:t>xdp_gen, 2 core sul nodo, un thread per coda, uscita separata · 64 byte, 30 settembre · arrivati = nodo successivo</a:t>
+              <a:t>xdp_gen, 1 ottobre, 64 byte, 3 giri · nodo su CPU 6 e 8, un thread per coda, uscita su CPU 3 e 5 · 2 × un core = 2 ÷ tempo di CPU della slide 13</a:t>
             </a:r>
             <a:endParaRPr lang="en-US" sz="1200"/>
           </a:p>
@@ -33451,7 +33451,7 @@
         </p:nvSpPr>
         <p:spPr bwMode="auto">
           <a:xfrm>
-            <a:off x="797917" y="3060700"/>
+            <a:off x="797917" y="3355732"/>
             <a:ext cx="321866" cy="238720"/>
           </a:xfrm>
           <a:prstGeom prst="rect">
@@ -33496,8 +33496,8 @@
         </p:nvSpPr>
         <p:spPr bwMode="auto">
           <a:xfrm>
-            <a:off x="736600" y="3274019"/>
-            <a:ext cx="393700" cy="1282700"/>
+            <a:off x="736600" y="3570616"/>
+            <a:ext cx="393700" cy="987668"/>
           </a:xfrm>
           <a:custGeom>
             <a:avLst/>
@@ -33552,7 +33552,7 @@
         </p:nvSpPr>
         <p:spPr bwMode="auto">
           <a:xfrm>
-            <a:off x="1234347" y="2270720"/>
+            <a:off x="1234347" y="2331720"/>
             <a:ext cx="312539" cy="228600"/>
           </a:xfrm>
           <a:prstGeom prst="rect">
@@ -33583,7 +33583,7 @@
                 <a:ea typeface="Carlito"/>
                 <a:cs typeface="Carlito"/>
               </a:rPr>
-              <a:t>7,50</a:t>
+              <a:t>9,41</a:t>
             </a:r>
             <a:endParaRPr lang="en-US" sz="1150"/>
           </a:p>
@@ -33597,8 +33597,8 @@
         </p:nvSpPr>
         <p:spPr bwMode="auto">
           <a:xfrm>
-            <a:off x="1168400" y="2473920"/>
-            <a:ext cx="393700" cy="2082800"/>
+            <a:off x="1168400" y="2546604"/>
+            <a:ext cx="393700" cy="2011680"/>
           </a:xfrm>
           <a:custGeom>
             <a:avLst/>
@@ -33653,7 +33653,7 @@
         </p:nvSpPr>
         <p:spPr bwMode="auto">
           <a:xfrm>
-            <a:off x="1877417" y="3397250"/>
+            <a:off x="1877417" y="3616545"/>
             <a:ext cx="321866" cy="238720"/>
           </a:xfrm>
           <a:prstGeom prst="rect">
@@ -33698,8 +33698,8 @@
         </p:nvSpPr>
         <p:spPr bwMode="auto">
           <a:xfrm>
-            <a:off x="1816100" y="3610569"/>
-            <a:ext cx="393700" cy="946150"/>
+            <a:off x="1816100" y="3831429"/>
+            <a:ext cx="393700" cy="726855"/>
           </a:xfrm>
           <a:custGeom>
             <a:avLst/>
@@ -33754,7 +33754,7 @@
         </p:nvSpPr>
         <p:spPr bwMode="auto">
           <a:xfrm>
-            <a:off x="2309216" y="2540000"/>
+            <a:off x="2309216" y="2906792"/>
             <a:ext cx="321866" cy="238720"/>
           </a:xfrm>
           <a:prstGeom prst="rect">
@@ -33785,7 +33785,7 @@
                 <a:ea typeface="Carlito"/>
                 <a:cs typeface="Carlito"/>
               </a:rPr>
-              <a:t>6,50</a:t>
+              <a:t>6,72</a:t>
             </a:r>
             <a:endParaRPr lang="en-US" sz="1200"/>
           </a:p>
@@ -33799,8 +33799,8 @@
         </p:nvSpPr>
         <p:spPr bwMode="auto">
           <a:xfrm>
-            <a:off x="2247900" y="2753319"/>
-            <a:ext cx="393700" cy="1803400"/>
+            <a:off x="2247900" y="3121676"/>
+            <a:ext cx="393700" cy="1436608"/>
           </a:xfrm>
           <a:custGeom>
             <a:avLst/>
@@ -33855,7 +33855,7 @@
         </p:nvSpPr>
         <p:spPr bwMode="auto">
           <a:xfrm>
-            <a:off x="2956917" y="3505199"/>
+            <a:off x="2956917" y="3699919"/>
             <a:ext cx="321866" cy="238720"/>
           </a:xfrm>
           <a:prstGeom prst="rect">
@@ -33900,8 +33900,8 @@
         </p:nvSpPr>
         <p:spPr bwMode="auto">
           <a:xfrm>
-            <a:off x="2895600" y="3718520"/>
-            <a:ext cx="393700" cy="838200"/>
+            <a:off x="2895600" y="3914803"/>
+            <a:ext cx="393700" cy="643481"/>
           </a:xfrm>
           <a:custGeom>
             <a:avLst/>
@@ -33956,7 +33956,7 @@
         </p:nvSpPr>
         <p:spPr bwMode="auto">
           <a:xfrm>
-            <a:off x="3388717" y="2743200"/>
+            <a:off x="3388717" y="3056438"/>
             <a:ext cx="321866" cy="238720"/>
           </a:xfrm>
           <a:prstGeom prst="rect">
@@ -33987,7 +33987,7 @@
                 <a:ea typeface="Carlito"/>
                 <a:cs typeface="Carlito"/>
               </a:rPr>
-              <a:t>5,76</a:t>
+              <a:t>6,02</a:t>
             </a:r>
             <a:endParaRPr lang="en-US" sz="1200"/>
           </a:p>
@@ -34001,8 +34001,8 @@
         </p:nvSpPr>
         <p:spPr bwMode="auto">
           <a:xfrm>
-            <a:off x="3327400" y="2956520"/>
-            <a:ext cx="393700" cy="1600200"/>
+            <a:off x="3327400" y="3271322"/>
+            <a:ext cx="393700" cy="1286962"/>
           </a:xfrm>
           <a:custGeom>
             <a:avLst/>
@@ -34057,7 +34057,7 @@
         </p:nvSpPr>
         <p:spPr bwMode="auto">
           <a:xfrm>
-            <a:off x="4036417" y="3543300"/>
+            <a:off x="4036417" y="3729849"/>
             <a:ext cx="321866" cy="238720"/>
           </a:xfrm>
           <a:prstGeom prst="rect">
@@ -34102,8 +34102,8 @@
         </p:nvSpPr>
         <p:spPr bwMode="auto">
           <a:xfrm>
-            <a:off x="3975100" y="3756620"/>
-            <a:ext cx="393700" cy="800100"/>
+            <a:off x="3975100" y="3944733"/>
+            <a:ext cx="393700" cy="613551"/>
           </a:xfrm>
           <a:custGeom>
             <a:avLst/>
@@ -34158,7 +34158,7 @@
         </p:nvSpPr>
         <p:spPr bwMode="auto">
           <a:xfrm>
-            <a:off x="4468217" y="2794000"/>
+            <a:off x="4468217" y="3141951"/>
             <a:ext cx="321866" cy="238720"/>
           </a:xfrm>
           <a:prstGeom prst="rect">
@@ -34189,7 +34189,7 @@
                 <a:ea typeface="Carlito"/>
                 <a:cs typeface="Carlito"/>
               </a:rPr>
-              <a:t>5,58</a:t>
+              <a:t>5,62</a:t>
             </a:r>
             <a:endParaRPr lang="en-US" sz="1200"/>
           </a:p>
@@ -34203,8 +34203,8 @@
         </p:nvSpPr>
         <p:spPr bwMode="auto">
           <a:xfrm>
-            <a:off x="4406900" y="3007320"/>
-            <a:ext cx="393700" cy="1549400"/>
+            <a:off x="4406900" y="3356835"/>
+            <a:ext cx="393700" cy="1201449"/>
           </a:xfrm>
           <a:custGeom>
             <a:avLst/>
@@ -34259,7 +34259,7 @@
         </p:nvSpPr>
         <p:spPr bwMode="auto">
           <a:xfrm>
-            <a:off x="5115917" y="3810000"/>
+            <a:off x="5115917" y="3935079"/>
             <a:ext cx="321866" cy="238720"/>
           </a:xfrm>
           <a:prstGeom prst="rect">
@@ -34304,8 +34304,8 @@
         </p:nvSpPr>
         <p:spPr bwMode="auto">
           <a:xfrm>
-            <a:off x="5054600" y="4023320"/>
-            <a:ext cx="393700" cy="533400"/>
+            <a:off x="5054600" y="4149963"/>
+            <a:ext cx="393700" cy="408321"/>
           </a:xfrm>
           <a:custGeom>
             <a:avLst/>
@@ -34360,7 +34360,7 @@
         </p:nvSpPr>
         <p:spPr bwMode="auto">
           <a:xfrm>
-            <a:off x="5547717" y="3308350"/>
+            <a:off x="5547717" y="3533170"/>
             <a:ext cx="321866" cy="238720"/>
           </a:xfrm>
           <a:prstGeom prst="rect">
@@ -34391,7 +34391,7 @@
                 <a:ea typeface="Carlito"/>
                 <a:cs typeface="Carlito"/>
               </a:rPr>
-              <a:t>3,72</a:t>
+              <a:t>3,79</a:t>
             </a:r>
             <a:endParaRPr lang="en-US" sz="1200"/>
           </a:p>
@@ -34405,8 +34405,8 @@
         </p:nvSpPr>
         <p:spPr bwMode="auto">
           <a:xfrm>
-            <a:off x="5486400" y="3521670"/>
-            <a:ext cx="393700" cy="1035050"/>
+            <a:off x="5486400" y="3748054"/>
+            <a:ext cx="393700" cy="810230"/>
           </a:xfrm>
           <a:custGeom>
             <a:avLst/>
@@ -34461,7 +34461,7 @@
         </p:nvSpPr>
         <p:spPr bwMode="auto">
           <a:xfrm>
-            <a:off x="6195417" y="3930650"/>
+            <a:off x="6195417" y="4024867"/>
             <a:ext cx="321866" cy="238720"/>
           </a:xfrm>
           <a:prstGeom prst="rect">
@@ -34506,8 +34506,8 @@
         </p:nvSpPr>
         <p:spPr bwMode="auto">
           <a:xfrm>
-            <a:off x="6134100" y="4143970"/>
-            <a:ext cx="393700" cy="412750"/>
+            <a:off x="6134100" y="4239751"/>
+            <a:ext cx="393700" cy="318533"/>
           </a:xfrm>
           <a:custGeom>
             <a:avLst/>
@@ -34562,7 +34562,7 @@
         </p:nvSpPr>
         <p:spPr bwMode="auto">
           <a:xfrm>
-            <a:off x="6627217" y="3524250"/>
+            <a:off x="6627217" y="3727711"/>
             <a:ext cx="321866" cy="238720"/>
           </a:xfrm>
           <a:prstGeom prst="rect">
@@ -34593,7 +34593,7 @@
                 <a:ea typeface="Carlito"/>
                 <a:cs typeface="Carlito"/>
               </a:rPr>
-              <a:t>2,95</a:t>
+              <a:t>2,88</a:t>
             </a:r>
             <a:endParaRPr lang="en-US" sz="1200"/>
           </a:p>
@@ -34607,8 +34607,8 @@
         </p:nvSpPr>
         <p:spPr bwMode="auto">
           <a:xfrm>
-            <a:off x="6565900" y="3737570"/>
-            <a:ext cx="393700" cy="819150"/>
+            <a:off x="6565900" y="3942595"/>
+            <a:ext cx="393700" cy="615689"/>
           </a:xfrm>
           <a:custGeom>
             <a:avLst/>
@@ -34964,7 +34964,7 @@
                 <a:ea typeface="Carlito"/>
                 <a:cs typeface="Carlito"/>
               </a:rPr>
-              <a:t>×1,62</a:t>
+              <a:t>×2,04</a:t>
             </a:r>
             <a:endParaRPr lang="en-US" sz="1300"/>
           </a:p>
@@ -35009,7 +35009,7 @@
                 <a:ea typeface="Carlito"/>
                 <a:cs typeface="Carlito"/>
               </a:rPr>
-              <a:t>×1,91</a:t>
+              <a:t>×1,98</a:t>
             </a:r>
             <a:endParaRPr lang="en-US" sz="1300"/>
           </a:p>
@@ -35054,7 +35054,7 @@
                 <a:ea typeface="Carlito"/>
                 <a:cs typeface="Carlito"/>
               </a:rPr>
-              <a:t>×1,91</a:t>
+              <a:t>×2,00</a:t>
             </a:r>
             <a:endParaRPr lang="en-US" sz="1300"/>
           </a:p>
@@ -35099,7 +35099,7 @@
                 <a:ea typeface="Carlito"/>
                 <a:cs typeface="Carlito"/>
               </a:rPr>
-              <a:t>×1,95</a:t>
+              <a:t>×1,96</a:t>
             </a:r>
             <a:endParaRPr lang="en-US" sz="1300"/>
           </a:p>
@@ -35144,7 +35144,7 @@
                 <a:ea typeface="Carlito"/>
                 <a:cs typeface="Carlito"/>
               </a:rPr>
-              <a:t>×1,95</a:t>
+              <a:t>×1,98</a:t>
             </a:r>
             <a:endParaRPr lang="en-US" sz="1300"/>
           </a:p>
@@ -35189,7 +35189,7 @@
                 <a:ea typeface="Carlito"/>
                 <a:cs typeface="Carlito"/>
               </a:rPr>
-              <a:t>×1,98</a:t>
+              <a:t>×1,93</a:t>
             </a:r>
             <a:endParaRPr lang="en-US" sz="1300"/>
           </a:p>
@@ -35482,7 +35482,7 @@
                 <a:ea typeface="Carlito"/>
                 <a:cs typeface="Carlito"/>
               </a:rPr>
-              <a:t>Perché rxonly cresce meno</a:t>
+              <a:t>Quattro thread, due per coda</a:t>
             </a:r>
             <a:endParaRPr lang="en-US" sz="1400"/>
           </a:p>
@@ -35527,7 +35527,7 @@
                 <a:ea typeface="Carlito"/>
                 <a:cs typeface="Carlito"/>
               </a:rPr>
-              <a:t>Tre thread su due code: due scrivono nella stessa coda e si intralciano (slide 13).</a:t>
+              <a:t>Con tre thread una coda ne aveva uno solo (~2,8 M/s): rxonly non saturava (×1,64).</a:t>
             </a:r>
             <a:endParaRPr lang="en-US" sz="1300"/>
           </a:p>
@@ -35865,7 +35865,7 @@
                 <a:ea typeface="Carlito"/>
                 <a:cs typeface="Carlito"/>
               </a:rPr>
-              <a:t>Il costo per pacchetto resta quello di un core: un nodo con N code regge circa </a:t>
+              <a:t>Il costo per pacchetto resta quello di un core: un nodo con N code regge </a:t>
             </a:r>
             <a:r>
               <a:rPr lang="en-US" sz="1500" b="1">
@@ -35876,7 +35876,7 @@
                 <a:ea typeface="Carlito"/>
                 <a:cs typeface="Carlito"/>
               </a:rPr>
-              <a:t>N volte</a:t>
+              <a:t>circa N volte</a:t>
             </a:r>
             <a:r>
               <a:rPr lang="en-US" sz="1500">
@@ -35887,7 +35887,7 @@
                 <a:ea typeface="Carlito"/>
                 <a:cs typeface="Carlito"/>
               </a:rPr>
-              <a:t> la capacità misurata su un core, finché generatore e scheda reggono.</a:t>
+              <a:t> la capacità misurata su un core, con pktgen e con xdp_gen (slide 14).</a:t>
             </a:r>
             <a:endParaRPr lang="en-US" sz="1500"/>
           </a:p>
@@ -35932,7 +35932,7 @@
                 <a:ea typeface="Carlito"/>
                 <a:cs typeface="Carlito"/>
               </a:rPr>
-              <a:t>pktgen a 3 thread, 64 byte, 3 giri · due code d'ingresso, una per core (CPU 6 e 8) · rapporto = 2 core / 1 core</a:t>
+              <a:t>pktgen a 4 thread, 2 per coda · una coda d'uscita per core (CPU 6 e 8) · 64 byte, 3 giri · 1 core: 28/9, 2 core: 1/10</a:t>
             </a:r>
             <a:endParaRPr lang="en-US" sz="1200"/>
           </a:p>
@@ -36734,7 +36734,7 @@
                 <a:ea typeface="Carlito"/>
                 <a:cs typeface="Carlito"/>
               </a:rPr>
-              <a:t>Il nodo satura alla sua capacità, il ritardo salta di un ordine di grandezza e la perdita è tutta all'ingresso: il collo di bottiglia è il programma, e la capacità cresce con i core.</a:t>
+              <a:t>Il nodo satura alla sua capacità, il ritardo salta di un ordine di grandezza e la perdita è tutta all'ingresso: il collo di bottiglia è il programma, e due core reggono il doppio.</a:t>
             </a:r>
             <a:endParaRPr lang="en-US" sz="1450"/>
           </a:p>

</xml_diff>

<commit_message>
Uno e due core nella stessa sessione (2026-10-01)
Rimisurati insieme, con l'alimentatore: pktgen a 1 core (3 thread) e a 2 core
(4 thread, 2 per coda), xdp_gen a 1 core e a 2 core (uscita su cpu3 e cpu5).
pktgen 1 -> 2 core: rapporti 1,93-1,99; xdp_gen 2 core: 97-99% del doppio per
P1-P3, tempo di CPU per core entro il 3,5% di quello a un core. xdp_gen a un
core: 117 / 124 / 292 / 432 ns (il 30-09 entro l'1%). Documenti, slide 10, 13,
14, 15, 23, 24 e spiegazioni aggiornati.

Co-Authored-By: Claude Opus 5.5 <noreply@anthropic.com>
</commit_message>
<xml_diff>
--- a/docs/Test reale su dual boot.pptx
+++ b/docs/Test reale su dual boot.pptx
@@ -4679,7 +4679,7 @@
                 <a:ea typeface="Carlito"/>
                 <a:cs typeface="Carlito"/>
               </a:rPr>
-              <a:t>293 ns</a:t>
+              <a:t>292 ns</a:t>
             </a:r>
             <a:endParaRPr lang="en-US" sz="3600"/>
           </a:p>
@@ -9349,7 +9349,7 @@
         <p:spPr bwMode="auto">
           <a:xfrm>
             <a:off x="1943100" y="2006600"/>
-            <a:ext cx="3300000" cy="279400"/>
+            <a:ext cx="3284700" cy="279400"/>
           </a:xfrm>
           <a:prstGeom prst="roundRect">
             <a:avLst>
@@ -9382,7 +9382,7 @@
         </p:nvSpPr>
         <p:spPr bwMode="auto">
           <a:xfrm>
-            <a:off x="5319300" y="2025650"/>
+            <a:off x="5306438" y="2025650"/>
             <a:ext cx="640000" cy="292100"/>
           </a:xfrm>
           <a:prstGeom prst="rect">
@@ -9413,7 +9413,7 @@
                 <a:ea typeface="Carlito"/>
                 <a:cs typeface="Carlito"/>
               </a:rPr>
-              <a:t>15,03</a:t>
+              <a:t>14,96</a:t>
             </a:r>
             <a:endParaRPr lang="en-US" sz="1500"/>
           </a:p>
@@ -9595,7 +9595,7 @@
         <p:spPr bwMode="auto">
           <a:xfrm>
             <a:off x="1943100" y="2463800"/>
-            <a:ext cx="2665469" cy="279400"/>
+            <a:ext cx="2724807" cy="279400"/>
           </a:xfrm>
           <a:prstGeom prst="roundRect">
             <a:avLst>
@@ -9628,7 +9628,7 @@
         </p:nvSpPr>
         <p:spPr bwMode="auto">
           <a:xfrm>
-            <a:off x="4684769" y="2482850"/>
+            <a:off x="4746545" y="2482850"/>
             <a:ext cx="640000" cy="292100"/>
           </a:xfrm>
           <a:prstGeom prst="rect">
@@ -9659,7 +9659,7 @@
                 <a:ea typeface="Carlito"/>
                 <a:cs typeface="Carlito"/>
               </a:rPr>
-              <a:t>12,14</a:t>
+              <a:t>12,41</a:t>
             </a:r>
             <a:endParaRPr lang="en-US" sz="1500"/>
           </a:p>
@@ -9704,7 +9704,7 @@
                 <a:ea typeface="Carlito"/>
                 <a:cs typeface="Carlito"/>
               </a:rPr>
-              <a:t>≈ 67 ns</a:t>
+              <a:t>≈ 65 ns</a:t>
             </a:r>
             <a:endParaRPr lang="en-US" sz="1400"/>
           </a:p>
@@ -9841,7 +9841,7 @@
         <p:spPr bwMode="auto">
           <a:xfrm>
             <a:off x="1943100" y="2921000"/>
-            <a:ext cx="1664271" cy="279400"/>
+            <a:ext cx="1666502" cy="279400"/>
           </a:xfrm>
           <a:prstGeom prst="roundRect">
             <a:avLst>
@@ -9872,7 +9872,7 @@
         </p:nvSpPr>
         <p:spPr bwMode="auto">
           <a:xfrm>
-            <a:off x="3683571" y="2940050"/>
+            <a:off x="3688240" y="2940050"/>
             <a:ext cx="640000" cy="292100"/>
           </a:xfrm>
           <a:prstGeom prst="rect">
@@ -9903,7 +9903,7 @@
                 <a:ea typeface="Carlito"/>
                 <a:cs typeface="Carlito"/>
               </a:rPr>
-              <a:t>7,58</a:t>
+              <a:t>7,59</a:t>
             </a:r>
             <a:endParaRPr lang="en-US" sz="1500"/>
           </a:p>
@@ -9948,7 +9948,7 @@
                 <a:ea typeface="Carlito"/>
                 <a:cs typeface="Carlito"/>
               </a:rPr>
-              <a:t>116 ns</a:t>
+              <a:t>117 ns</a:t>
             </a:r>
             <a:endParaRPr lang="en-US" sz="1400"/>
           </a:p>
@@ -10085,7 +10085,7 @@
         <p:spPr bwMode="auto">
           <a:xfrm>
             <a:off x="1943100" y="3378200"/>
-            <a:ext cx="1486427" cy="279400"/>
+            <a:ext cx="1554523" cy="279400"/>
           </a:xfrm>
           <a:prstGeom prst="roundRect">
             <a:avLst>
@@ -10116,7 +10116,7 @@
         </p:nvSpPr>
         <p:spPr bwMode="auto">
           <a:xfrm>
-            <a:off x="3505727" y="3397250"/>
+            <a:off x="3576261" y="3397250"/>
             <a:ext cx="640000" cy="292100"/>
           </a:xfrm>
           <a:prstGeom prst="rect">
@@ -10147,7 +10147,7 @@
                 <a:ea typeface="Carlito"/>
                 <a:cs typeface="Carlito"/>
               </a:rPr>
-              <a:t>6,77</a:t>
+              <a:t>7,08</a:t>
             </a:r>
             <a:endParaRPr lang="en-US" sz="1500"/>
           </a:p>
@@ -10192,7 +10192,7 @@
                 <a:ea typeface="Carlito"/>
                 <a:cs typeface="Carlito"/>
               </a:rPr>
-              <a:t>125 ns</a:t>
+              <a:t>124 ns</a:t>
             </a:r>
             <a:endParaRPr lang="en-US" sz="1400"/>
           </a:p>
@@ -10329,7 +10329,7 @@
         <p:spPr bwMode="auto">
           <a:xfrm>
             <a:off x="1943100" y="3835400"/>
-            <a:ext cx="658682" cy="279400"/>
+            <a:ext cx="652109" cy="279400"/>
           </a:xfrm>
           <a:prstGeom prst="roundRect">
             <a:avLst>
@@ -10360,7 +10360,7 @@
         </p:nvSpPr>
         <p:spPr bwMode="auto">
           <a:xfrm>
-            <a:off x="2677982" y="3854450"/>
+            <a:off x="2673847" y="3854450"/>
             <a:ext cx="640000" cy="292100"/>
           </a:xfrm>
           <a:prstGeom prst="rect">
@@ -10391,7 +10391,7 @@
                 <a:ea typeface="Carlito"/>
                 <a:cs typeface="Carlito"/>
               </a:rPr>
-              <a:t>3,00</a:t>
+              <a:t>2,97</a:t>
             </a:r>
             <a:endParaRPr lang="en-US" sz="1500"/>
           </a:p>
@@ -10436,7 +10436,7 @@
                 <a:ea typeface="Carlito"/>
                 <a:cs typeface="Carlito"/>
               </a:rPr>
-              <a:t>293 ns</a:t>
+              <a:t>292 ns</a:t>
             </a:r>
             <a:endParaRPr lang="en-US" sz="1400"/>
           </a:p>
@@ -10573,7 +10573,7 @@
         <p:spPr bwMode="auto">
           <a:xfrm>
             <a:off x="1943100" y="4292600"/>
-            <a:ext cx="432534" cy="279400"/>
+            <a:ext cx="441326" cy="279400"/>
           </a:xfrm>
           <a:prstGeom prst="roundRect">
             <a:avLst>
@@ -10604,7 +10604,7 @@
         </p:nvSpPr>
         <p:spPr bwMode="auto">
           <a:xfrm>
-            <a:off x="2451834" y="4311650"/>
+            <a:off x="2463064" y="4311650"/>
             <a:ext cx="640000" cy="292100"/>
           </a:xfrm>
           <a:prstGeom prst="rect">
@@ -10635,7 +10635,7 @@
                 <a:ea typeface="Carlito"/>
                 <a:cs typeface="Carlito"/>
               </a:rPr>
-              <a:t>1,97</a:t>
+              <a:t>2,01</a:t>
             </a:r>
             <a:endParaRPr lang="en-US" sz="1500"/>
           </a:p>
@@ -10680,7 +10680,7 @@
                 <a:ea typeface="Carlito"/>
                 <a:cs typeface="Carlito"/>
               </a:rPr>
-              <a:t>428 ns</a:t>
+              <a:t>432 ns</a:t>
             </a:r>
             <a:endParaRPr lang="en-US" sz="1400"/>
           </a:p>
@@ -11085,7 +11085,7 @@
                 <a:ea typeface="Carlito"/>
                 <a:cs typeface="Carlito"/>
               </a:rPr>
-              <a:t>: 116, 125, 293 e 428 ns di CPU. Baseline e rxonly, con un thread, non saturano: i loro valori sono indicativi.</a:t>
+              <a:t>: 117, 124, 292 e 432 ns di CPU. Baseline e rxonly, con un thread, non saturano: i loro valori sono indicativi.</a:t>
             </a:r>
             <a:endParaRPr lang="en-US" sz="1500"/>
           </a:p>
@@ -11535,7 +11535,7 @@
         </p:nvSpPr>
         <p:spPr bwMode="auto">
           <a:xfrm>
-            <a:off x="836016" y="2443218"/>
+            <a:off x="836016" y="2479407"/>
             <a:ext cx="420000" cy="238720"/>
           </a:xfrm>
           <a:prstGeom prst="rect">
@@ -11566,7 +11566,7 @@
                 <a:ea typeface="Carlito"/>
                 <a:cs typeface="Carlito"/>
               </a:rPr>
-              <a:t>28,33</a:t>
+              <a:t>28,80</a:t>
             </a:r>
             <a:endParaRPr lang="en-US" sz="1200"/>
           </a:p>
@@ -11580,8 +11580,8 @@
         </p:nvSpPr>
         <p:spPr bwMode="auto">
           <a:xfrm>
-            <a:off x="736600" y="2658102"/>
-            <a:ext cx="469900" cy="1822458"/>
+            <a:off x="736600" y="2694291"/>
+            <a:ext cx="469900" cy="1786269"/>
           </a:xfrm>
           <a:custGeom>
             <a:avLst/>
@@ -11636,7 +11636,7 @@
         </p:nvSpPr>
         <p:spPr bwMode="auto">
           <a:xfrm>
-            <a:off x="1356717" y="2345388"/>
+            <a:off x="1356717" y="2345452"/>
             <a:ext cx="420000" cy="238720"/>
           </a:xfrm>
           <a:prstGeom prst="rect">
@@ -11667,7 +11667,7 @@
                 <a:ea typeface="Carlito"/>
                 <a:cs typeface="Carlito"/>
               </a:rPr>
-              <a:t>29,85</a:t>
+              <a:t>30,96</a:t>
             </a:r>
             <a:endParaRPr lang="en-US" sz="1200"/>
           </a:p>
@@ -11681,8 +11681,8 @@
         </p:nvSpPr>
         <p:spPr bwMode="auto">
           <a:xfrm>
-            <a:off x="1257300" y="2560272"/>
-            <a:ext cx="469900" cy="1920288"/>
+            <a:off x="1257300" y="2560336"/>
+            <a:ext cx="469900" cy="1920224"/>
           </a:xfrm>
           <a:custGeom>
             <a:avLst/>
@@ -11737,7 +11737,7 @@
         </p:nvSpPr>
         <p:spPr bwMode="auto">
           <a:xfrm>
-            <a:off x="2112367" y="3168856"/>
+            <a:off x="2112367" y="3237951"/>
             <a:ext cx="420000" cy="238720"/>
           </a:xfrm>
           <a:prstGeom prst="rect">
@@ -11768,7 +11768,7 @@
                 <a:ea typeface="Carlito"/>
                 <a:cs typeface="Carlito"/>
               </a:rPr>
-              <a:t>17,05</a:t>
+              <a:t>16,57</a:t>
             </a:r>
             <a:endParaRPr lang="en-US" sz="1200"/>
           </a:p>
@@ -11782,8 +11782,8 @@
         </p:nvSpPr>
         <p:spPr bwMode="auto">
           <a:xfrm>
-            <a:off x="2012949" y="3383740"/>
-            <a:ext cx="469900" cy="1096820"/>
+            <a:off x="2012949" y="3452835"/>
+            <a:ext cx="469900" cy="1027725"/>
           </a:xfrm>
           <a:custGeom>
             <a:avLst/>
@@ -11838,7 +11838,7 @@
         </p:nvSpPr>
         <p:spPr bwMode="auto">
           <a:xfrm>
-            <a:off x="2633067" y="3156545"/>
+            <a:off x="2633067" y="3201813"/>
             <a:ext cx="420000" cy="238720"/>
           </a:xfrm>
           <a:prstGeom prst="rect">
@@ -11869,7 +11869,7 @@
                 <a:ea typeface="Carlito"/>
                 <a:cs typeface="Carlito"/>
               </a:rPr>
-              <a:t>17,24</a:t>
+              <a:t>17,15</a:t>
             </a:r>
             <a:endParaRPr lang="en-US" sz="1200"/>
           </a:p>
@@ -11883,8 +11883,8 @@
         </p:nvSpPr>
         <p:spPr bwMode="auto">
           <a:xfrm>
-            <a:off x="2533650" y="3371429"/>
-            <a:ext cx="469900" cy="1109131"/>
+            <a:off x="2533650" y="3416697"/>
+            <a:ext cx="469900" cy="1063863"/>
           </a:xfrm>
           <a:custGeom>
             <a:avLst/>
@@ -11939,7 +11939,7 @@
         </p:nvSpPr>
         <p:spPr bwMode="auto">
           <a:xfrm>
-            <a:off x="3388717" y="3248625"/>
+            <a:off x="3388717" y="3280747"/>
             <a:ext cx="420000" cy="238720"/>
           </a:xfrm>
           <a:prstGeom prst="rect">
@@ -11970,7 +11970,7 @@
                 <a:ea typeface="Carlito"/>
                 <a:cs typeface="Carlito"/>
               </a:rPr>
-              <a:t>15,81</a:t>
+              <a:t>15,88</a:t>
             </a:r>
             <a:endParaRPr lang="en-US" sz="1200"/>
           </a:p>
@@ -11984,8 +11984,8 @@
         </p:nvSpPr>
         <p:spPr bwMode="auto">
           <a:xfrm>
-            <a:off x="3289300" y="3463509"/>
-            <a:ext cx="469900" cy="1017051"/>
+            <a:off x="3289300" y="3495631"/>
+            <a:ext cx="469900" cy="984929"/>
           </a:xfrm>
           <a:custGeom>
             <a:avLst/>
@@ -12040,7 +12040,7 @@
         </p:nvSpPr>
         <p:spPr bwMode="auto">
           <a:xfrm>
-            <a:off x="3909417" y="3236402"/>
+            <a:off x="3909417" y="3265301"/>
             <a:ext cx="420000" cy="238720"/>
           </a:xfrm>
           <a:prstGeom prst="rect">
@@ -12071,7 +12071,7 @@
                 <a:ea typeface="Carlito"/>
                 <a:cs typeface="Carlito"/>
               </a:rPr>
-              <a:t>16,00</a:t>
+              <a:t>16,13</a:t>
             </a:r>
             <a:endParaRPr lang="en-US" sz="1200"/>
           </a:p>
@@ -12085,8 +12085,8 @@
         </p:nvSpPr>
         <p:spPr bwMode="auto">
           <a:xfrm>
-            <a:off x="3810000" y="3451286"/>
-            <a:ext cx="469900" cy="1029274"/>
+            <a:off x="3810000" y="3480185"/>
+            <a:ext cx="469900" cy="1000375"/>
           </a:xfrm>
           <a:custGeom>
             <a:avLst/>
@@ -12141,7 +12141,7 @@
         </p:nvSpPr>
         <p:spPr bwMode="auto">
           <a:xfrm>
-            <a:off x="4665067" y="3835954"/>
+            <a:off x="4665067" y="3847640"/>
             <a:ext cx="420000" cy="238720"/>
           </a:xfrm>
           <a:prstGeom prst="rect">
@@ -12172,7 +12172,7 @@
                 <a:ea typeface="Carlito"/>
                 <a:cs typeface="Carlito"/>
               </a:rPr>
-              <a:t>6,68</a:t>
+              <a:t>6,74</a:t>
             </a:r>
             <a:endParaRPr lang="en-US" sz="1200"/>
           </a:p>
@@ -12186,8 +12186,8 @@
         </p:nvSpPr>
         <p:spPr bwMode="auto">
           <a:xfrm>
-            <a:off x="4565650" y="4050838"/>
-            <a:ext cx="469900" cy="429722"/>
+            <a:off x="4565650" y="4062524"/>
+            <a:ext cx="469900" cy="418036"/>
           </a:xfrm>
           <a:custGeom>
             <a:avLst/>
@@ -12242,7 +12242,7 @@
         </p:nvSpPr>
         <p:spPr bwMode="auto">
           <a:xfrm>
-            <a:off x="5185767" y="3826566"/>
+            <a:off x="5185767" y="3841296"/>
             <a:ext cx="420000" cy="238720"/>
           </a:xfrm>
           <a:prstGeom prst="rect">
@@ -12273,7 +12273,7 @@
                 <a:ea typeface="Carlito"/>
                 <a:cs typeface="Carlito"/>
               </a:rPr>
-              <a:t>6,83</a:t>
+              <a:t>6,84</a:t>
             </a:r>
             <a:endParaRPr lang="en-US" sz="1200"/>
           </a:p>
@@ -12287,8 +12287,8 @@
         </p:nvSpPr>
         <p:spPr bwMode="auto">
           <a:xfrm>
-            <a:off x="5086350" y="4041450"/>
-            <a:ext cx="469900" cy="439110"/>
+            <a:off x="5086350" y="4056180"/>
+            <a:ext cx="469900" cy="424380"/>
           </a:xfrm>
           <a:custGeom>
             <a:avLst/>
@@ -12343,7 +12343,7 @@
         </p:nvSpPr>
         <p:spPr bwMode="auto">
           <a:xfrm>
-            <a:off x="5941417" y="3969117"/>
+            <a:off x="5941417" y="3983471"/>
             <a:ext cx="420000" cy="238720"/>
           </a:xfrm>
           <a:prstGeom prst="rect">
@@ -12374,7 +12374,7 @@
                 <a:ea typeface="Carlito"/>
                 <a:cs typeface="Carlito"/>
               </a:rPr>
-              <a:t>4,61</a:t>
+              <a:t>4,55</a:t>
             </a:r>
             <a:endParaRPr lang="en-US" sz="1200"/>
           </a:p>
@@ -12388,8 +12388,8 @@
         </p:nvSpPr>
         <p:spPr bwMode="auto">
           <a:xfrm>
-            <a:off x="5842000" y="4184001"/>
-            <a:ext cx="469900" cy="296559"/>
+            <a:off x="5842000" y="4198355"/>
+            <a:ext cx="469900" cy="282205"/>
           </a:xfrm>
           <a:custGeom>
             <a:avLst/>
@@ -12444,7 +12444,7 @@
         </p:nvSpPr>
         <p:spPr bwMode="auto">
           <a:xfrm>
-            <a:off x="6462117" y="3965071"/>
+            <a:off x="6462117" y="3978199"/>
             <a:ext cx="420000" cy="238720"/>
           </a:xfrm>
           <a:prstGeom prst="rect">
@@ -12475,7 +12475,7 @@
                 <a:ea typeface="Carlito"/>
                 <a:cs typeface="Carlito"/>
               </a:rPr>
-              <a:t>4,67</a:t>
+              <a:t>4,63</a:t>
             </a:r>
             <a:endParaRPr lang="en-US" sz="1200"/>
           </a:p>
@@ -12489,8 +12489,8 @@
         </p:nvSpPr>
         <p:spPr bwMode="auto">
           <a:xfrm>
-            <a:off x="6362700" y="4179955"/>
-            <a:ext cx="469900" cy="300605"/>
+            <a:off x="6362700" y="4193083"/>
+            <a:ext cx="469900" cy="287477"/>
           </a:xfrm>
           <a:custGeom>
             <a:avLst/>
@@ -13094,7 +13094,7 @@
                 <a:ea typeface="Carlito"/>
                 <a:cs typeface="Carlito"/>
               </a:rPr>
-              <a:t>Tempo di CPU per pacchetto di ogni core: 68, 117, 127, 298 e 434 ns, contro 67, 116, 125, 293 e 428 con un core solo (slide 13).</a:t>
+              <a:t>Tempo di CPU per pacchetto di ogni core: 68, 121, 126, 297 e 439 ns, contro 65, 117, 124, 292 e 432 con un core solo (slide 13).</a:t>
             </a:r>
             <a:endParaRPr lang="en-US" sz="1300"/>
           </a:p>
@@ -13274,7 +13274,7 @@
                 <a:ea typeface="Carlito"/>
                 <a:cs typeface="Carlito"/>
               </a:rPr>
-              <a:t>95–99% del doppio</a:t>
+              <a:t>97–99% del doppio</a:t>
             </a:r>
             <a:r>
               <a:rPr lang="en-US" sz="1500">
@@ -13285,7 +13285,7 @@
                 <a:ea typeface="Carlito"/>
                 <a:cs typeface="Carlito"/>
               </a:rPr>
-              <a:t> di un core: il costo misurato su un core vale per ogni core.</a:t>
+              <a:t> di un core (P1–P3): il costo misurato su un core vale per ogni core.</a:t>
             </a:r>
             <a:endParaRPr lang="en-US" sz="1500"/>
           </a:p>
@@ -13903,7 +13903,7 @@
         <p:spPr bwMode="auto">
           <a:xfrm>
             <a:off x="1689100" y="2600920"/>
-            <a:ext cx="388821" cy="203200"/>
+            <a:ext cx="374985" cy="203200"/>
           </a:xfrm>
           <a:prstGeom prst="roundRect">
             <a:avLst>
@@ -13936,7 +13936,7 @@
         </p:nvSpPr>
         <p:spPr bwMode="auto">
           <a:xfrm>
-            <a:off x="2154121" y="2607270"/>
+            <a:off x="2142519" y="2607270"/>
             <a:ext cx="1066800" cy="256514"/>
           </a:xfrm>
           <a:prstGeom prst="rect">
@@ -13967,7 +13967,7 @@
                 <a:ea typeface="Carlito"/>
                 <a:cs typeface="Carlito"/>
               </a:rPr>
-              <a:t>≈ 67 ns</a:t>
+              <a:t>≈ 65 ns</a:t>
             </a:r>
             <a:endParaRPr lang="en-US" sz="1300"/>
           </a:p>
@@ -14104,7 +14104,7 @@
         <p:spPr bwMode="auto">
           <a:xfrm>
             <a:off x="1689100" y="3121620"/>
-            <a:ext cx="673183" cy="203200"/>
+            <a:ext cx="676830" cy="203200"/>
           </a:xfrm>
           <a:prstGeom prst="roundRect">
             <a:avLst>
@@ -14135,7 +14135,7 @@
         </p:nvSpPr>
         <p:spPr bwMode="auto">
           <a:xfrm>
-            <a:off x="2438483" y="3127970"/>
+            <a:off x="2444364" y="3127970"/>
             <a:ext cx="1700000" cy="256514"/>
           </a:xfrm>
           <a:prstGeom prst="rect">
@@ -14166,7 +14166,7 @@
                 <a:ea typeface="Carlito"/>
                 <a:cs typeface="Carlito"/>
               </a:rPr>
-              <a:t>116 ns   −224 ns</a:t>
+              <a:t>117 ns   −223 ns</a:t>
             </a:r>
             <a:endParaRPr lang="en-US" sz="1300"/>
           </a:p>
@@ -14303,7 +14303,7 @@
         <p:spPr bwMode="auto">
           <a:xfrm>
             <a:off x="1689100" y="3642320"/>
-            <a:ext cx="725413" cy="203200"/>
+            <a:ext cx="719785" cy="203200"/>
           </a:xfrm>
           <a:prstGeom prst="roundRect">
             <a:avLst>
@@ -14334,7 +14334,7 @@
         </p:nvSpPr>
         <p:spPr bwMode="auto">
           <a:xfrm>
-            <a:off x="2490713" y="3648670"/>
+            <a:off x="2487319" y="3648670"/>
             <a:ext cx="1700000" cy="256514"/>
           </a:xfrm>
           <a:prstGeom prst="rect">
@@ -14365,7 +14365,7 @@
                 <a:ea typeface="Carlito"/>
                 <a:cs typeface="Carlito"/>
               </a:rPr>
-              <a:t>125 ns   −231 ns</a:t>
+              <a:t>124 ns   −232 ns</a:t>
             </a:r>
             <a:endParaRPr lang="en-US" sz="1300"/>
           </a:p>
@@ -14502,7 +14502,7 @@
         <p:spPr bwMode="auto">
           <a:xfrm>
             <a:off x="1689100" y="4163020"/>
-            <a:ext cx="1700369" cy="203200"/>
+            <a:ext cx="1696720" cy="203200"/>
           </a:xfrm>
           <a:prstGeom prst="roundRect">
             <a:avLst>
@@ -14533,7 +14533,7 @@
         </p:nvSpPr>
         <p:spPr bwMode="auto">
           <a:xfrm>
-            <a:off x="3465669" y="4169370"/>
+            <a:off x="3464254" y="4169370"/>
             <a:ext cx="685800" cy="256514"/>
           </a:xfrm>
           <a:prstGeom prst="rect">
@@ -14564,7 +14564,7 @@
                 <a:ea typeface="Carlito"/>
                 <a:cs typeface="Carlito"/>
               </a:rPr>
-              <a:t>293 ns</a:t>
+              <a:t>292 ns</a:t>
             </a:r>
             <a:endParaRPr lang="en-US" sz="1300"/>
           </a:p>
@@ -14578,7 +14578,7 @@
         </p:nvSpPr>
         <p:spPr bwMode="auto">
           <a:xfrm>
-            <a:off x="4208619" y="4169370"/>
+            <a:off x="4204918" y="4169370"/>
             <a:ext cx="1193800" cy="256514"/>
           </a:xfrm>
           <a:prstGeom prst="rect">
@@ -14609,7 +14609,7 @@
                 <a:ea typeface="Carlito"/>
                 <a:cs typeface="Carlito"/>
               </a:rPr>
-              <a:t>−236 ns</a:t>
+              <a:t>−237 ns</a:t>
             </a:r>
             <a:endParaRPr lang="en-US" sz="1300"/>
           </a:p>
@@ -14746,7 +14746,7 @@
         <p:spPr bwMode="auto">
           <a:xfrm>
             <a:off x="1689100" y="4683720"/>
-            <a:ext cx="2483815" cy="203200"/>
+            <a:ext cx="2504738" cy="203200"/>
           </a:xfrm>
           <a:prstGeom prst="roundRect">
             <a:avLst>
@@ -14777,7 +14777,7 @@
         </p:nvSpPr>
         <p:spPr bwMode="auto">
           <a:xfrm>
-            <a:off x="4249115" y="4690070"/>
+            <a:off x="4272272" y="4690070"/>
             <a:ext cx="685800" cy="256514"/>
           </a:xfrm>
           <a:prstGeom prst="rect">
@@ -14808,7 +14808,7 @@
                 <a:ea typeface="Carlito"/>
                 <a:cs typeface="Carlito"/>
               </a:rPr>
-              <a:t>428 ns</a:t>
+              <a:t>432 ns</a:t>
             </a:r>
             <a:endParaRPr lang="en-US" sz="1300"/>
           </a:p>
@@ -14822,7 +14822,7 @@
         </p:nvSpPr>
         <p:spPr bwMode="auto">
           <a:xfrm>
-            <a:off x="4992065" y="4690070"/>
+            <a:off x="5012936" y="4690070"/>
             <a:ext cx="1193800" cy="256514"/>
           </a:xfrm>
           <a:prstGeom prst="rect">
@@ -14853,7 +14853,7 @@
                 <a:ea typeface="Carlito"/>
                 <a:cs typeface="Carlito"/>
               </a:rPr>
-              <a:t>−238 ns</a:t>
+              <a:t>−234 ns</a:t>
             </a:r>
             <a:endParaRPr lang="en-US" sz="1300"/>
           </a:p>
@@ -15191,7 +15191,7 @@
                 <a:ea typeface="Carlito"/>
                 <a:cs typeface="Carlito"/>
               </a:rPr>
-              <a:t>116, 125, 293 e 428 ns di CPU, un thread per coda. Baseline ≈ 67 ns: indicativa.</a:t>
+              <a:t>117, 124, 292 e 432 ns di CPU, un thread per coda. Baseline ≈ 65 ns: indicativa.</a:t>
             </a:r>
             <a:endParaRPr lang="en-US" sz="1300"/>
           </a:p>
@@ -15596,7 +15596,7 @@
                 <a:ea typeface="Carlito"/>
                 <a:cs typeface="Carlito"/>
               </a:rPr>
-              <a:t>pktgen del 28 settembre, xdp_gen del 30 (tempo di CPU) · P1: 340 − 116 = 224 · P1.5: 356 − 125 = 231 · P2: 529 − 293 = 236 · P3: 666 − 428 = 238 ns</a:t>
+              <a:t>pktgen 28/9, xdp_gen 1/10 (tempo di CPU) · P1: 340 − 117 = 223 · P1.5: 356 − 124 = 232 · P2: 529 − 292 = 237 · P3: 666 − 432 = 234 ns</a:t>
             </a:r>
             <a:endParaRPr lang="en-US" sz="1200"/>
           </a:p>
@@ -33451,7 +33451,7 @@
         </p:nvSpPr>
         <p:spPr bwMode="auto">
           <a:xfrm>
-            <a:off x="797917" y="3355732"/>
+            <a:off x="797917" y="3340767"/>
             <a:ext cx="321866" cy="238720"/>
           </a:xfrm>
           <a:prstGeom prst="rect">
@@ -33482,7 +33482,7 @@
                 <a:ea typeface="Carlito"/>
                 <a:cs typeface="Carlito"/>
               </a:rPr>
-              <a:t>4,62</a:t>
+              <a:t>4,69</a:t>
             </a:r>
             <a:endParaRPr lang="en-US" sz="1200"/>
           </a:p>
@@ -33496,8 +33496,8 @@
         </p:nvSpPr>
         <p:spPr bwMode="auto">
           <a:xfrm>
-            <a:off x="736600" y="3570616"/>
-            <a:ext cx="393700" cy="987668"/>
+            <a:off x="736600" y="3555651"/>
+            <a:ext cx="393700" cy="1002633"/>
           </a:xfrm>
           <a:custGeom>
             <a:avLst/>
@@ -33552,7 +33552,7 @@
         </p:nvSpPr>
         <p:spPr bwMode="auto">
           <a:xfrm>
-            <a:off x="1234347" y="2331720"/>
+            <a:off x="1234347" y="2357374"/>
             <a:ext cx="312539" cy="228600"/>
           </a:xfrm>
           <a:prstGeom prst="rect">
@@ -33583,7 +33583,7 @@
                 <a:ea typeface="Carlito"/>
                 <a:cs typeface="Carlito"/>
               </a:rPr>
-              <a:t>9,41</a:t>
+              <a:t>9,29</a:t>
             </a:r>
             <a:endParaRPr lang="en-US" sz="1150"/>
           </a:p>
@@ -33597,8 +33597,8 @@
         </p:nvSpPr>
         <p:spPr bwMode="auto">
           <a:xfrm>
-            <a:off x="1168400" y="2546604"/>
-            <a:ext cx="393700" cy="2011680"/>
+            <a:off x="1168400" y="2572258"/>
+            <a:ext cx="393700" cy="1986026"/>
           </a:xfrm>
           <a:custGeom>
             <a:avLst/>
@@ -33653,7 +33653,7 @@
         </p:nvSpPr>
         <p:spPr bwMode="auto">
           <a:xfrm>
-            <a:off x="1877417" y="3616545"/>
+            <a:off x="1877417" y="3614407"/>
             <a:ext cx="321866" cy="238720"/>
           </a:xfrm>
           <a:prstGeom prst="rect">
@@ -33684,7 +33684,7 @@
                 <a:ea typeface="Carlito"/>
                 <a:cs typeface="Carlito"/>
               </a:rPr>
-              <a:t>3,40</a:t>
+              <a:t>3,41</a:t>
             </a:r>
             <a:endParaRPr lang="en-US" sz="1200"/>
           </a:p>
@@ -33698,8 +33698,8 @@
         </p:nvSpPr>
         <p:spPr bwMode="auto">
           <a:xfrm>
-            <a:off x="1816100" y="3831429"/>
-            <a:ext cx="393700" cy="726855"/>
+            <a:off x="1816100" y="3829291"/>
+            <a:ext cx="393700" cy="728993"/>
           </a:xfrm>
           <a:custGeom>
             <a:avLst/>
@@ -33855,7 +33855,7 @@
         </p:nvSpPr>
         <p:spPr bwMode="auto">
           <a:xfrm>
-            <a:off x="2956917" y="3699919"/>
+            <a:off x="2956917" y="3702057"/>
             <a:ext cx="321866" cy="238720"/>
           </a:xfrm>
           <a:prstGeom prst="rect">
@@ -33886,7 +33886,7 @@
                 <a:ea typeface="Carlito"/>
                 <a:cs typeface="Carlito"/>
               </a:rPr>
-              <a:t>3,01</a:t>
+              <a:t>3,00</a:t>
             </a:r>
             <a:endParaRPr lang="en-US" sz="1200"/>
           </a:p>
@@ -33900,8 +33900,8 @@
         </p:nvSpPr>
         <p:spPr bwMode="auto">
           <a:xfrm>
-            <a:off x="2895600" y="3914803"/>
-            <a:ext cx="393700" cy="643481"/>
+            <a:off x="2895600" y="3916941"/>
+            <a:ext cx="393700" cy="641343"/>
           </a:xfrm>
           <a:custGeom>
             <a:avLst/>
@@ -33956,7 +33956,7 @@
         </p:nvSpPr>
         <p:spPr bwMode="auto">
           <a:xfrm>
-            <a:off x="3388717" y="3056438"/>
+            <a:off x="3388717" y="3069265"/>
             <a:ext cx="321866" cy="238720"/>
           </a:xfrm>
           <a:prstGeom prst="rect">
@@ -33987,7 +33987,7 @@
                 <a:ea typeface="Carlito"/>
                 <a:cs typeface="Carlito"/>
               </a:rPr>
-              <a:t>6,02</a:t>
+              <a:t>5,96</a:t>
             </a:r>
             <a:endParaRPr lang="en-US" sz="1200"/>
           </a:p>
@@ -34001,8 +34001,8 @@
         </p:nvSpPr>
         <p:spPr bwMode="auto">
           <a:xfrm>
-            <a:off x="3327400" y="3271322"/>
-            <a:ext cx="393700" cy="1286962"/>
+            <a:off x="3327400" y="3284149"/>
+            <a:ext cx="393700" cy="1274135"/>
           </a:xfrm>
           <a:custGeom>
             <a:avLst/>
@@ -34057,7 +34057,7 @@
         </p:nvSpPr>
         <p:spPr bwMode="auto">
           <a:xfrm>
-            <a:off x="4036417" y="3729849"/>
+            <a:off x="4036417" y="3731987"/>
             <a:ext cx="321866" cy="238720"/>
           </a:xfrm>
           <a:prstGeom prst="rect">
@@ -34088,7 +34088,7 @@
                 <a:ea typeface="Carlito"/>
                 <a:cs typeface="Carlito"/>
               </a:rPr>
-              <a:t>2,87</a:t>
+              <a:t>2,86</a:t>
             </a:r>
             <a:endParaRPr lang="en-US" sz="1200"/>
           </a:p>
@@ -34102,8 +34102,8 @@
         </p:nvSpPr>
         <p:spPr bwMode="auto">
           <a:xfrm>
-            <a:off x="3975100" y="3944733"/>
-            <a:ext cx="393700" cy="613551"/>
+            <a:off x="3975100" y="3946871"/>
+            <a:ext cx="393700" cy="611413"/>
           </a:xfrm>
           <a:custGeom>
             <a:avLst/>
@@ -34158,7 +34158,7 @@
         </p:nvSpPr>
         <p:spPr bwMode="auto">
           <a:xfrm>
-            <a:off x="4468217" y="3141951"/>
+            <a:off x="4468217" y="3146226"/>
             <a:ext cx="321866" cy="238720"/>
           </a:xfrm>
           <a:prstGeom prst="rect">
@@ -34189,7 +34189,7 @@
                 <a:ea typeface="Carlito"/>
                 <a:cs typeface="Carlito"/>
               </a:rPr>
-              <a:t>5,62</a:t>
+              <a:t>5,60</a:t>
             </a:r>
             <a:endParaRPr lang="en-US" sz="1200"/>
           </a:p>
@@ -34203,8 +34203,8 @@
         </p:nvSpPr>
         <p:spPr bwMode="auto">
           <a:xfrm>
-            <a:off x="4406900" y="3356835"/>
-            <a:ext cx="393700" cy="1201449"/>
+            <a:off x="4406900" y="3361110"/>
+            <a:ext cx="393700" cy="1197174"/>
           </a:xfrm>
           <a:custGeom>
             <a:avLst/>
@@ -34259,7 +34259,7 @@
         </p:nvSpPr>
         <p:spPr bwMode="auto">
           <a:xfrm>
-            <a:off x="5115917" y="3935079"/>
+            <a:off x="5115917" y="3937216"/>
             <a:ext cx="321866" cy="238720"/>
           </a:xfrm>
           <a:prstGeom prst="rect">
@@ -34290,7 +34290,7 @@
                 <a:ea typeface="Carlito"/>
                 <a:cs typeface="Carlito"/>
               </a:rPr>
-              <a:t>1,91</a:t>
+              <a:t>1,90</a:t>
             </a:r>
             <a:endParaRPr lang="en-US" sz="1200"/>
           </a:p>
@@ -34304,8 +34304,8 @@
         </p:nvSpPr>
         <p:spPr bwMode="auto">
           <a:xfrm>
-            <a:off x="5054600" y="4149963"/>
-            <a:ext cx="393700" cy="408321"/>
+            <a:off x="5054600" y="4152100"/>
+            <a:ext cx="393700" cy="406184"/>
           </a:xfrm>
           <a:custGeom>
             <a:avLst/>
@@ -34360,7 +34360,7 @@
         </p:nvSpPr>
         <p:spPr bwMode="auto">
           <a:xfrm>
-            <a:off x="5547717" y="3533170"/>
+            <a:off x="5547717" y="3556686"/>
             <a:ext cx="321866" cy="238720"/>
           </a:xfrm>
           <a:prstGeom prst="rect">
@@ -34391,7 +34391,7 @@
                 <a:ea typeface="Carlito"/>
                 <a:cs typeface="Carlito"/>
               </a:rPr>
-              <a:t>3,79</a:t>
+              <a:t>3,68</a:t>
             </a:r>
             <a:endParaRPr lang="en-US" sz="1200"/>
           </a:p>
@@ -34405,8 +34405,8 @@
         </p:nvSpPr>
         <p:spPr bwMode="auto">
           <a:xfrm>
-            <a:off x="5486400" y="3748054"/>
-            <a:ext cx="393700" cy="810230"/>
+            <a:off x="5486400" y="3771570"/>
+            <a:ext cx="393700" cy="786714"/>
           </a:xfrm>
           <a:custGeom>
             <a:avLst/>
@@ -34461,7 +34461,7 @@
         </p:nvSpPr>
         <p:spPr bwMode="auto">
           <a:xfrm>
-            <a:off x="6195417" y="4024867"/>
+            <a:off x="6195417" y="4031280"/>
             <a:ext cx="321866" cy="238720"/>
           </a:xfrm>
           <a:prstGeom prst="rect">
@@ -34492,7 +34492,7 @@
                 <a:ea typeface="Carlito"/>
                 <a:cs typeface="Carlito"/>
               </a:rPr>
-              <a:t>1,49</a:t>
+              <a:t>1,46</a:t>
             </a:r>
             <a:endParaRPr lang="en-US" sz="1200"/>
           </a:p>
@@ -34506,8 +34506,8 @@
         </p:nvSpPr>
         <p:spPr bwMode="auto">
           <a:xfrm>
-            <a:off x="6134100" y="4239751"/>
-            <a:ext cx="393700" cy="318533"/>
+            <a:off x="6134100" y="4246164"/>
+            <a:ext cx="393700" cy="312120"/>
           </a:xfrm>
           <a:custGeom>
             <a:avLst/>
@@ -34562,7 +34562,7 @@
         </p:nvSpPr>
         <p:spPr bwMode="auto">
           <a:xfrm>
-            <a:off x="6627217" y="3727711"/>
+            <a:off x="6627217" y="3742676"/>
             <a:ext cx="321866" cy="238720"/>
           </a:xfrm>
           <a:prstGeom prst="rect">
@@ -34593,7 +34593,7 @@
                 <a:ea typeface="Carlito"/>
                 <a:cs typeface="Carlito"/>
               </a:rPr>
-              <a:t>2,88</a:t>
+              <a:t>2,81</a:t>
             </a:r>
             <a:endParaRPr lang="en-US" sz="1200"/>
           </a:p>
@@ -34607,8 +34607,8 @@
         </p:nvSpPr>
         <p:spPr bwMode="auto">
           <a:xfrm>
-            <a:off x="6565900" y="3942595"/>
-            <a:ext cx="393700" cy="615689"/>
+            <a:off x="6565900" y="3957560"/>
+            <a:ext cx="393700" cy="600724"/>
           </a:xfrm>
           <a:custGeom>
             <a:avLst/>
@@ -34964,7 +34964,7 @@
                 <a:ea typeface="Carlito"/>
                 <a:cs typeface="Carlito"/>
               </a:rPr>
-              <a:t>×2,04</a:t>
+              <a:t>×1,98</a:t>
             </a:r>
             <a:endParaRPr lang="en-US" sz="1300"/>
           </a:p>
@@ -35009,7 +35009,7 @@
                 <a:ea typeface="Carlito"/>
                 <a:cs typeface="Carlito"/>
               </a:rPr>
-              <a:t>×1,98</a:t>
+              <a:t>×1,97</a:t>
             </a:r>
             <a:endParaRPr lang="en-US" sz="1300"/>
           </a:p>
@@ -35054,7 +35054,7 @@
                 <a:ea typeface="Carlito"/>
                 <a:cs typeface="Carlito"/>
               </a:rPr>
-              <a:t>×2,00</a:t>
+              <a:t>×1,99</a:t>
             </a:r>
             <a:endParaRPr lang="en-US" sz="1300"/>
           </a:p>
@@ -35144,7 +35144,7 @@
                 <a:ea typeface="Carlito"/>
                 <a:cs typeface="Carlito"/>
               </a:rPr>
-              <a:t>×1,98</a:t>
+              <a:t>×1,94</a:t>
             </a:r>
             <a:endParaRPr lang="en-US" sz="1300"/>
           </a:p>
@@ -35527,7 +35527,7 @@
                 <a:ea typeface="Carlito"/>
                 <a:cs typeface="Carlito"/>
               </a:rPr>
-              <a:t>Con tre thread una coda ne aveva uno solo (~2,8 M/s): rxonly non saturava (×1,64).</a:t>
+              <a:t>Con tre thread una coda ne aveva uno solo (~2,8 M/s): rxonly non saturava (×1,61).</a:t>
             </a:r>
             <a:endParaRPr lang="en-US" sz="1300"/>
           </a:p>
@@ -35932,7 +35932,7 @@
                 <a:ea typeface="Carlito"/>
                 <a:cs typeface="Carlito"/>
               </a:rPr>
-              <a:t>pktgen a 4 thread, 2 per coda · una coda d'uscita per core (CPU 6 e 8) · 64 byte, 3 giri · 1 core: 28/9, 2 core: 1/10</a:t>
+              <a:t>pktgen, 3 thread su 1 core, 4 (2 per coda) su 2 · una coda d'uscita per core · 64 byte, 3 giri, 1 ottobre</a:t>
             </a:r>
             <a:endParaRPr lang="en-US" sz="1200"/>
           </a:p>
@@ -36535,7 +36535,7 @@
                 <a:ea typeface="Carlito"/>
                 <a:cs typeface="Carlito"/>
               </a:rPr>
-              <a:t>pktgen confronta tutte le pipeline, da 3,31 a 1,50 M/s. xdp_gen, un thread per coda, misura P1–P3 senza la copia: 116–428 ns.</a:t>
+              <a:t>pktgen confronta tutte le pipeline, da 3,31 a 1,50 M/s. xdp_gen, un thread per coda, misura P1–P3 senza la copia: 117–432 ns.</a:t>
             </a:r>
             <a:endParaRPr lang="en-US" sz="1450"/>
           </a:p>

</xml_diff>